<commit_message>
updating the country calculation results
</commit_message>
<xml_diff>
--- a/personal/country-comparison-2026/Boss-Country-FIRE-Deck.pptx
+++ b/personal/country-comparison-2026/Boss-Country-FIRE-Deck.pptx
@@ -250,7 +250,7 @@
                   <c:v>15</c:v>
                 </c:pt>
                 <c:pt idx="6">
-                  <c:v>15</c:v>
+                  <c:v>16</c:v>
                 </c:pt>
                 <c:pt idx="7">
                   <c:v>17</c:v>
@@ -528,7 +528,7 @@
                   <c:v>1.65</c:v>
                 </c:pt>
                 <c:pt idx="6">
-                  <c:v>1.65</c:v>
+                  <c:v>1.95</c:v>
                 </c:pt>
                 <c:pt idx="7">
                   <c:v>2.4</c:v>
@@ -4049,7 +4049,7 @@
                 <a:ea typeface="Calibri" pitchFamily="34" charset="-122"/>
                 <a:cs typeface="Calibri" pitchFamily="34" charset="-120"/>
               </a:rPr>
-              <a:t>Prepared by Lexi · 2026-05-05 · Built on FIRE-Dashboard.html calc engine + 2026 visa research</a:t>
+              <a:t>Prepared by Lexi · 2026-05-06 · Built on FIRE-Dashboard.html calc engine + 2026 visa research</a:t>
             </a:r>
             <a:endParaRPr lang="en-US" sz="900" dirty="0"/>
           </a:p>
@@ -8525,7 +8525,7 @@
                 <a:ea typeface="Georgia" pitchFamily="34" charset="-122"/>
                 <a:cs typeface="Georgia" pitchFamily="34" charset="-120"/>
               </a:rPr>
-              <a:t>57</a:t>
+              <a:t>58</a:t>
             </a:r>
             <a:endParaRPr lang="en-US" sz="3600" dirty="0"/>
           </a:p>
@@ -8564,7 +8564,7 @@
                 <a:ea typeface="Calibri" pitchFamily="34" charset="-122"/>
                 <a:cs typeface="Calibri" pitchFamily="34" charset="-120"/>
               </a:rPr>
-              <a:t>15 years from today</a:t>
+              <a:t>16 years from today</a:t>
             </a:r>
             <a:endParaRPr lang="en-US" sz="1100" dirty="0"/>
           </a:p>
@@ -8682,7 +8682,7 @@
                 <a:ea typeface="Georgia" pitchFamily="34" charset="-122"/>
                 <a:cs typeface="Georgia" pitchFamily="34" charset="-120"/>
               </a:rPr>
-              <a:t>$66k</a:t>
+              <a:t>$78k</a:t>
             </a:r>
             <a:endParaRPr lang="en-US" sz="3600" dirty="0"/>
           </a:p>
@@ -8721,7 +8721,7 @@
                 <a:ea typeface="Calibri" pitchFamily="34" charset="-122"/>
                 <a:cs typeface="Calibri" pitchFamily="34" charset="-120"/>
               </a:rPr>
-              <a:t>$6k / month</a:t>
+              <a:t>$7k / month</a:t>
             </a:r>
             <a:endParaRPr lang="en-US" sz="1100" dirty="0"/>
           </a:p>
@@ -8839,7 +8839,7 @@
                 <a:ea typeface="Georgia" pitchFamily="34" charset="-122"/>
                 <a:cs typeface="Georgia" pitchFamily="34" charset="-120"/>
               </a:rPr>
-              <a:t>$1.65M</a:t>
+              <a:t>$1.95M</a:t>
             </a:r>
             <a:endParaRPr lang="en-US" sz="3600" dirty="0"/>
           </a:p>
@@ -9015,7 +9015,7 @@
                 <a:ea typeface="Calibri" pitchFamily="34" charset="-122"/>
                 <a:cs typeface="Calibri" pitchFamily="34" charset="-120"/>
               </a:rPr>
-              <a:t>$696k (today's $)</a:t>
+              <a:t>$1.02M (today's $)</a:t>
             </a:r>
             <a:endParaRPr lang="en-US" sz="1200" dirty="0"/>
           </a:p>
@@ -9093,7 +9093,7 @@
                 <a:ea typeface="Calibri" pitchFamily="34" charset="-122"/>
                 <a:cs typeface="Calibri" pitchFamily="34" charset="-120"/>
               </a:rPr>
-              <a:t>$1.38M</a:t>
+              <a:t>$1.59M</a:t>
             </a:r>
             <a:endParaRPr lang="en-US" sz="1200" dirty="0"/>
           </a:p>
@@ -9171,7 +9171,7 @@
                 <a:ea typeface="Calibri" pitchFamily="34" charset="-122"/>
                 <a:cs typeface="Calibri" pitchFamily="34" charset="-120"/>
               </a:rPr>
-              <a:t>$1.18M</a:t>
+              <a:t>$1.37M</a:t>
             </a:r>
             <a:endParaRPr lang="en-US" sz="1200" dirty="0"/>
           </a:p>
@@ -9249,7 +9249,7 @@
                 <a:ea typeface="Calibri" pitchFamily="34" charset="-122"/>
                 <a:cs typeface="Calibri" pitchFamily="34" charset="-120"/>
               </a:rPr>
-              <a:t>$3.83M</a:t>
+              <a:t>$4.52M</a:t>
             </a:r>
             <a:endParaRPr lang="en-US" sz="1200" dirty="0"/>
           </a:p>
@@ -15222,7 +15222,7 @@
                 <a:ea typeface="Calibri" pitchFamily="34" charset="-122"/>
                 <a:cs typeface="Calibri" pitchFamily="34" charset="-120"/>
               </a:rPr>
-              <a:t>$57k / yr</a:t>
+              <a:t>$63k / yr</a:t>
             </a:r>
             <a:endParaRPr lang="en-US" sz="1600" dirty="0"/>
           </a:p>
@@ -15495,7 +15495,7 @@
                 <a:ea typeface="Calibri" pitchFamily="34" charset="-122"/>
                 <a:cs typeface="Calibri" pitchFamily="34" charset="-120"/>
               </a:rPr>
-              <a:t>$1.29M</a:t>
+              <a:t>$892k</a:t>
             </a:r>
             <a:endParaRPr lang="en-US" sz="1000" dirty="0"/>
           </a:p>
@@ -15769,7 +15769,7 @@
                 <a:ea typeface="Calibri" pitchFamily="34" charset="-122"/>
                 <a:cs typeface="Calibri" pitchFamily="34" charset="-120"/>
               </a:rPr>
-              <a:t>$60k / yr</a:t>
+              <a:t>$69k / yr</a:t>
             </a:r>
             <a:endParaRPr lang="en-US" sz="1600" dirty="0"/>
           </a:p>
@@ -15808,7 +15808,7 @@
                 <a:ea typeface="Calibri" pitchFamily="34" charset="-122"/>
                 <a:cs typeface="Calibri" pitchFamily="34" charset="-120"/>
               </a:rPr>
-              <a:t>$5k/mo blended</a:t>
+              <a:t>$6k/mo blended</a:t>
             </a:r>
             <a:endParaRPr lang="en-US" sz="1100" dirty="0"/>
           </a:p>
@@ -16042,7 +16042,7 @@
                 <a:ea typeface="Calibri" pitchFamily="34" charset="-122"/>
                 <a:cs typeface="Calibri" pitchFamily="34" charset="-120"/>
               </a:rPr>
-              <a:t>$1.09M</a:t>
+              <a:t>$500k</a:t>
             </a:r>
             <a:endParaRPr lang="en-US" sz="1000" dirty="0"/>
           </a:p>
@@ -16160,7 +16160,7 @@
                 <a:ea typeface="Calibri" pitchFamily="34" charset="-122"/>
                 <a:cs typeface="Calibri" pitchFamily="34" charset="-120"/>
               </a:rPr>
-              <a:t>FASTEST FIRE</a:t>
+              <a:t>BEST WEATHER + COST</a:t>
             </a:r>
             <a:endParaRPr lang="en-US" sz="1100" dirty="0"/>
           </a:p>
@@ -16238,7 +16238,7 @@
                 <a:ea typeface="Georgia" pitchFamily="34" charset="-122"/>
                 <a:cs typeface="Georgia" pitchFamily="34" charset="-120"/>
               </a:rPr>
-              <a:t>Age 56</a:t>
+              <a:t>Age 57</a:t>
             </a:r>
             <a:endParaRPr lang="en-US" sz="4400" dirty="0"/>
           </a:p>
@@ -16277,7 +16277,7 @@
                 <a:ea typeface="Calibri" pitchFamily="34" charset="-122"/>
                 <a:cs typeface="Calibri" pitchFamily="34" charset="-120"/>
               </a:rPr>
-              <a:t>14 years from today</a:t>
+              <a:t>15 years from today</a:t>
             </a:r>
             <a:endParaRPr lang="en-US" sz="1200" dirty="0"/>
           </a:p>
@@ -16316,7 +16316,7 @@
                 <a:ea typeface="Calibri" pitchFamily="34" charset="-122"/>
                 <a:cs typeface="Calibri" pitchFamily="34" charset="-120"/>
               </a:rPr>
-              <a:t>$51k / yr</a:t>
+              <a:t>$57k / yr</a:t>
             </a:r>
             <a:endParaRPr lang="en-US" sz="1600" dirty="0"/>
           </a:p>
@@ -16355,7 +16355,7 @@
                 <a:ea typeface="Calibri" pitchFamily="34" charset="-122"/>
                 <a:cs typeface="Calibri" pitchFamily="34" charset="-120"/>
               </a:rPr>
-              <a:t>$4k/mo blended</a:t>
+              <a:t>$5k/mo blended</a:t>
             </a:r>
             <a:endParaRPr lang="en-US" sz="1100" dirty="0"/>
           </a:p>
@@ -16589,7 +16589,7 @@
                 <a:ea typeface="Calibri" pitchFamily="34" charset="-122"/>
                 <a:cs typeface="Calibri" pitchFamily="34" charset="-120"/>
               </a:rPr>
-              <a:t>$678k</a:t>
+              <a:t>$1.29M</a:t>
             </a:r>
             <a:endParaRPr lang="en-US" sz="1000" dirty="0"/>
           </a:p>
@@ -20702,7 +20702,7 @@
                           <a:ea typeface="Calibri" pitchFamily="34" charset="-122"/>
                           <a:cs typeface="Calibri" pitchFamily="34" charset="-120"/>
                         </a:rPr>
-                        <a:t>57</a:t>
+                        <a:t>58</a:t>
                       </a:r>
                       <a:endParaRPr lang="en-US" sz="1100" dirty="0">
                         <a:latin typeface="Calibri" charset="0"/>
@@ -20770,7 +20770,7 @@
                           <a:ea typeface="Calibri" pitchFamily="34" charset="-122"/>
                           <a:cs typeface="Calibri" pitchFamily="34" charset="-120"/>
                         </a:rPr>
-                        <a:t>$66k</a:t>
+                        <a:t>$78k</a:t>
                       </a:r>
                       <a:endParaRPr lang="en-US" sz="1100" dirty="0">
                         <a:latin typeface="Calibri" charset="0"/>
@@ -20838,7 +20838,7 @@
                           <a:ea typeface="Calibri" pitchFamily="34" charset="-122"/>
                           <a:cs typeface="Calibri" pitchFamily="34" charset="-120"/>
                         </a:rPr>
-                        <a:t>$1.65M</a:t>
+                        <a:t>$1.95M</a:t>
                       </a:r>
                       <a:endParaRPr lang="en-US" sz="1100" dirty="0">
                         <a:latin typeface="Calibri" charset="0"/>
@@ -20906,7 +20906,7 @@
                           <a:ea typeface="Calibri" pitchFamily="34" charset="-122"/>
                           <a:cs typeface="Calibri" pitchFamily="34" charset="-120"/>
                         </a:rPr>
-                        <a:t>$1.63M</a:t>
+                        <a:t>$1.74M</a:t>
                       </a:r>
                       <a:endParaRPr lang="en-US" sz="1100" dirty="0">
                         <a:latin typeface="Calibri" charset="0"/>
@@ -20974,7 +20974,7 @@
                           <a:ea typeface="Calibri" pitchFamily="34" charset="-122"/>
                           <a:cs typeface="Calibri" pitchFamily="34" charset="-120"/>
                         </a:rPr>
-                        <a:t>$2.53M</a:t>
+                        <a:t>$2.79M</a:t>
                       </a:r>
                       <a:endParaRPr lang="en-US" sz="1100" dirty="0">
                         <a:latin typeface="Calibri" charset="0"/>
@@ -21042,7 +21042,7 @@
                           <a:ea typeface="Calibri" pitchFamily="34" charset="-122"/>
                           <a:cs typeface="Calibri" pitchFamily="34" charset="-120"/>
                         </a:rPr>
-                        <a:t>-1%</a:t>
+                        <a:t>-11%</a:t>
                       </a:r>
                       <a:endParaRPr lang="en-US" sz="1100" dirty="0">
                         <a:latin typeface="Calibri" charset="0"/>
@@ -21726,7 +21726,7 @@
                           <a:ea typeface="Calibri" pitchFamily="34" charset="-122"/>
                           <a:cs typeface="Calibri" pitchFamily="34" charset="-120"/>
                         </a:rPr>
-                        <a:t>$57k</a:t>
+                        <a:t>$63k</a:t>
                       </a:r>
                       <a:endParaRPr lang="en-US" sz="1100" dirty="0">
                         <a:latin typeface="Calibri" charset="0"/>
@@ -21794,7 +21794,7 @@
                           <a:ea typeface="Calibri" pitchFamily="34" charset="-122"/>
                           <a:cs typeface="Calibri" pitchFamily="34" charset="-120"/>
                         </a:rPr>
-                        <a:t>$1.43M</a:t>
+                        <a:t>$1.57M</a:t>
                       </a:r>
                       <a:endParaRPr lang="en-US" sz="1100" dirty="0">
                         <a:latin typeface="Calibri" charset="0"/>
@@ -21862,7 +21862,7 @@
                           <a:ea typeface="Calibri" pitchFamily="34" charset="-122"/>
                           <a:cs typeface="Calibri" pitchFamily="34" charset="-120"/>
                         </a:rPr>
-                        <a:t>$1.64M</a:t>
+                        <a:t>$1.63M</a:t>
                       </a:r>
                       <a:endParaRPr lang="en-US" sz="1100" dirty="0">
                         <a:latin typeface="Calibri" charset="0"/>
@@ -21930,7 +21930,7 @@
                           <a:ea typeface="Calibri" pitchFamily="34" charset="-122"/>
                           <a:cs typeface="Calibri" pitchFamily="34" charset="-120"/>
                         </a:rPr>
-                        <a:t>$2.55M</a:t>
+                        <a:t>$2.54M</a:t>
                       </a:r>
                       <a:endParaRPr lang="en-US" sz="1100" dirty="0">
                         <a:latin typeface="Calibri" charset="0"/>
@@ -21998,7 +21998,7 @@
                           <a:ea typeface="Calibri" pitchFamily="34" charset="-122"/>
                           <a:cs typeface="Calibri" pitchFamily="34" charset="-120"/>
                         </a:rPr>
-                        <a:t>+15%</a:t>
+                        <a:t>+3%</a:t>
                       </a:r>
                       <a:endParaRPr lang="en-US" sz="1100" dirty="0">
                         <a:latin typeface="Calibri" charset="0"/>
@@ -22204,7 +22204,7 @@
                           <a:ea typeface="Calibri" pitchFamily="34" charset="-122"/>
                           <a:cs typeface="Calibri" pitchFamily="34" charset="-120"/>
                         </a:rPr>
-                        <a:t>$60k</a:t>
+                        <a:t>$69k</a:t>
                       </a:r>
                       <a:endParaRPr lang="en-US" sz="1100" dirty="0">
                         <a:latin typeface="Calibri" charset="0"/>
@@ -22272,7 +22272,7 @@
                           <a:ea typeface="Calibri" pitchFamily="34" charset="-122"/>
                           <a:cs typeface="Calibri" pitchFamily="34" charset="-120"/>
                         </a:rPr>
-                        <a:t>$1.50M</a:t>
+                        <a:t>$1.73M</a:t>
                       </a:r>
                       <a:endParaRPr lang="en-US" sz="1100" dirty="0">
                         <a:latin typeface="Calibri" charset="0"/>
@@ -22340,7 +22340,7 @@
                           <a:ea typeface="Calibri" pitchFamily="34" charset="-122"/>
                           <a:cs typeface="Calibri" pitchFamily="34" charset="-120"/>
                         </a:rPr>
-                        <a:t>$1.63M</a:t>
+                        <a:t>$1.62M</a:t>
                       </a:r>
                       <a:endParaRPr lang="en-US" sz="1100" dirty="0">
                         <a:latin typeface="Calibri" charset="0"/>
@@ -22408,7 +22408,7 @@
                           <a:ea typeface="Calibri" pitchFamily="34" charset="-122"/>
                           <a:cs typeface="Calibri" pitchFamily="34" charset="-120"/>
                         </a:rPr>
-                        <a:t>$2.54M</a:t>
+                        <a:t>$2.53M</a:t>
                       </a:r>
                       <a:endParaRPr lang="en-US" sz="1100" dirty="0">
                         <a:latin typeface="Calibri" charset="0"/>
@@ -22470,13 +22470,13 @@
                       <a:r>
                         <a:rPr lang="en-US" sz="1100" b="1" dirty="0">
                           <a:solidFill>
-                            <a:srgbClr val="2C9F6B"/>
+                            <a:srgbClr val="C04B4B"/>
                           </a:solidFill>
                           <a:latin typeface="Calibri" pitchFamily="34" charset="0"/>
                           <a:ea typeface="Calibri" pitchFamily="34" charset="-122"/>
                           <a:cs typeface="Calibri" pitchFamily="34" charset="-120"/>
                         </a:rPr>
-                        <a:t>+9%</a:t>
+                        <a:t>-6%</a:t>
                       </a:r>
                       <a:endParaRPr lang="en-US" sz="1100" dirty="0">
                         <a:latin typeface="Calibri" charset="0"/>
@@ -22614,7 +22614,7 @@
                           <a:ea typeface="Calibri" pitchFamily="34" charset="-122"/>
                           <a:cs typeface="Calibri" pitchFamily="34" charset="-120"/>
                         </a:rPr>
-                        <a:t>56</a:t>
+                        <a:t>57</a:t>
                       </a:r>
                       <a:endParaRPr lang="en-US" sz="1100" dirty="0">
                         <a:latin typeface="Calibri" charset="0"/>
@@ -22682,7 +22682,7 @@
                           <a:ea typeface="Calibri" pitchFamily="34" charset="-122"/>
                           <a:cs typeface="Calibri" pitchFamily="34" charset="-120"/>
                         </a:rPr>
-                        <a:t>$51k</a:t>
+                        <a:t>$57k</a:t>
                       </a:r>
                       <a:endParaRPr lang="en-US" sz="1100" dirty="0">
                         <a:latin typeface="Calibri" charset="0"/>
@@ -22750,7 +22750,7 @@
                           <a:ea typeface="Calibri" pitchFamily="34" charset="-122"/>
                           <a:cs typeface="Calibri" pitchFamily="34" charset="-120"/>
                         </a:rPr>
-                        <a:t>$1.27M</a:t>
+                        <a:t>$1.43M</a:t>
                       </a:r>
                       <a:endParaRPr lang="en-US" sz="1100" dirty="0">
                         <a:latin typeface="Calibri" charset="0"/>
@@ -22818,7 +22818,7 @@
                           <a:ea typeface="Calibri" pitchFamily="34" charset="-122"/>
                           <a:cs typeface="Calibri" pitchFamily="34" charset="-120"/>
                         </a:rPr>
-                        <a:t>$1.52M</a:t>
+                        <a:t>$1.64M</a:t>
                       </a:r>
                       <a:endParaRPr lang="en-US" sz="1100" dirty="0">
                         <a:latin typeface="Calibri" charset="0"/>
@@ -22886,7 +22886,7 @@
                           <a:ea typeface="Calibri" pitchFamily="34" charset="-122"/>
                           <a:cs typeface="Calibri" pitchFamily="34" charset="-120"/>
                         </a:rPr>
-                        <a:t>$2.30M</a:t>
+                        <a:t>$2.55M</a:t>
                       </a:r>
                       <a:endParaRPr lang="en-US" sz="1100" dirty="0">
                         <a:latin typeface="Calibri" charset="0"/>
@@ -22954,7 +22954,7 @@
                           <a:ea typeface="Calibri" pitchFamily="34" charset="-122"/>
                           <a:cs typeface="Calibri" pitchFamily="34" charset="-120"/>
                         </a:rPr>
-                        <a:t>+19%</a:t>
+                        <a:t>+15%</a:t>
                       </a:r>
                       <a:endParaRPr lang="en-US" sz="1100" dirty="0">
                         <a:latin typeface="Calibri" charset="0"/>
@@ -27295,7 +27295,7 @@
                 <a:ea typeface="Calibri" pitchFamily="34" charset="-122"/>
                 <a:cs typeface="Calibri" pitchFamily="34" charset="-120"/>
               </a:rPr>
-              <a:t>LEXI'S CALL: Plan A (Japan + Philippines) wins on cost ($51k), FIRE age (56), flight time (4 hr), language (English official), and weather sync (PH dry season Dec-May aligns perfectly with Japan winter escape).</a:t>
+              <a:t>LEXI'S CALL: Plan A (Japan + Philippines) wins on cost ($57k), FIRE age (57), flight time (4 hr), language (English official), and weather sync (PH dry season Dec-May aligns perfectly with Japan winter escape).</a:t>
             </a:r>
             <a:endParaRPr lang="en-US" sz="1200" dirty="0"/>
           </a:p>
@@ -29285,7 +29285,7 @@
                 <a:ea typeface="Georgia" pitchFamily="34" charset="-122"/>
                 <a:cs typeface="Georgia" pitchFamily="34" charset="-120"/>
               </a:rPr>
-              <a:t>Age 56</a:t>
+              <a:t>Age 57</a:t>
             </a:r>
             <a:endParaRPr lang="en-US" sz="3200" dirty="0"/>
           </a:p>
@@ -29324,7 +29324,7 @@
                 <a:ea typeface="Calibri" pitchFamily="34" charset="-122"/>
                 <a:cs typeface="Calibri" pitchFamily="34" charset="-120"/>
               </a:rPr>
-              <a:t>14 yrs - $51k/yr</a:t>
+              <a:t>15 yrs - $57k/yr</a:t>
             </a:r>
             <a:endParaRPr lang="en-US" sz="1200" dirty="0"/>
           </a:p>
@@ -29753,7 +29753,7 @@
                 <a:ea typeface="Calibri" pitchFamily="34" charset="-122"/>
                 <a:cs typeface="Calibri" pitchFamily="34" charset="-120"/>
               </a:rPr>
-              <a:t>Cheapest, fastest FIRE, easiest visa, English, perfect weather sync.</a:t>
+              <a:t>Cheapest hybrid, easiest visa, English, perfect weather sync.</a:t>
             </a:r>
             <a:endParaRPr lang="en-US" sz="1000" dirty="0"/>
           </a:p>
@@ -29949,7 +29949,7 @@
                 <a:ea typeface="Calibri" pitchFamily="34" charset="-122"/>
                 <a:cs typeface="Calibri" pitchFamily="34" charset="-120"/>
               </a:rPr>
-              <a:t>15 yrs - $60k/yr</a:t>
+              <a:t>15 yrs - $69k/yr</a:t>
             </a:r>
             <a:endParaRPr lang="en-US" sz="1200" dirty="0"/>
           </a:p>
@@ -30574,7 +30574,7 @@
                 <a:ea typeface="Calibri" pitchFamily="34" charset="-122"/>
                 <a:cs typeface="Calibri" pitchFamily="34" charset="-120"/>
               </a:rPr>
-              <a:t>15 yrs - $57k/yr</a:t>
+              <a:t>15 yrs - $63k/yr</a:t>
             </a:r>
             <a:endParaRPr lang="en-US" sz="1200" dirty="0"/>
           </a:p>
@@ -38039,7 +38039,7 @@
                           <a:ea typeface="Calibri" pitchFamily="34" charset="-122"/>
                           <a:cs typeface="Calibri" pitchFamily="34" charset="-120"/>
                         </a:rPr>
-                        <a:t>$66k</a:t>
+                        <a:t>$78k</a:t>
                       </a:r>
                       <a:endParaRPr lang="en-US" sz="1100" dirty="0">
                         <a:latin typeface="Calibri" charset="0"/>
@@ -38107,7 +38107,7 @@
                           <a:ea typeface="Calibri" pitchFamily="34" charset="-122"/>
                           <a:cs typeface="Calibri" pitchFamily="34" charset="-120"/>
                         </a:rPr>
-                        <a:t>57</a:t>
+                        <a:t>58</a:t>
                       </a:r>
                       <a:endParaRPr lang="en-US" sz="1100" dirty="0">
                         <a:latin typeface="Calibri" charset="0"/>
@@ -38175,7 +38175,7 @@
                           <a:ea typeface="Calibri" pitchFamily="34" charset="-122"/>
                           <a:cs typeface="Calibri" pitchFamily="34" charset="-120"/>
                         </a:rPr>
-                        <a:t>15</a:t>
+                        <a:t>16</a:t>
                       </a:r>
                       <a:endParaRPr lang="en-US" sz="1100" dirty="0">
                         <a:latin typeface="Calibri" charset="0"/>
@@ -38243,7 +38243,7 @@
                           <a:ea typeface="Calibri" pitchFamily="34" charset="-122"/>
                           <a:cs typeface="Calibri" pitchFamily="34" charset="-120"/>
                         </a:rPr>
-                        <a:t>$1.65M</a:t>
+                        <a:t>$1.95M</a:t>
                       </a:r>
                       <a:endParaRPr lang="en-US" sz="1100" dirty="0">
                         <a:latin typeface="Calibri" charset="0"/>
@@ -38311,7 +38311,7 @@
                           <a:ea typeface="Calibri" pitchFamily="34" charset="-122"/>
                           <a:cs typeface="Calibri" pitchFamily="34" charset="-120"/>
                         </a:rPr>
-                        <a:t>$696k</a:t>
+                        <a:t>$1.02M</a:t>
                       </a:r>
                       <a:endParaRPr lang="en-US" sz="1100" dirty="0">
                         <a:latin typeface="Calibri" charset="0"/>

</xml_diff>